<commit_message>
Add dedicated References slide to presentation and PDF
</commit_message>
<xml_diff>
--- a/CNN_KLETech_Final_Updated_With_Results.pptx
+++ b/CNN_KLETech_Final_Updated_With_Results.pptx
@@ -33,6 +33,7 @@
     <p:sldId id="282" r:id="rId35"/>
     <p:sldId id="283" r:id="rId36"/>
     <p:sldId id="284" r:id="rId37"/>
+    <p:sldId id="285" r:id="rId38"/>
   </p:sldIdLst>
   <p:sldSz cy="5143500" cx="9144000"/>
   <p:notesSz cx="5143500" cy="9144000"/>
@@ -15977,6 +15978,580 @@
               <a:buNone/>
             </a:pPr>
             <a:r>
+              <a:t>References</a:t>
+            </a:r>
+            <a:endParaRPr b="0" i="0" sz="2400" u="none" cap="none" strike="noStrike">
+              <a:solidFill>
+                <a:schemeClr val="dk1"/>
+              </a:solidFill>
+              <a:latin typeface="Calibri"/>
+              <a:ea typeface="Calibri"/>
+              <a:cs typeface="Calibri"/>
+              <a:sym typeface="Calibri"/>
+            </a:endParaRPr>
+          </a:p>
+        </p:txBody>
+      </p:sp>
+      <p:sp>
+        <p:nvSpPr>
+          <p:cNvPr id="60" name="Rounded Rectangle 59"/>
+          <p:cNvSpPr/>
+          <p:nvPr/>
+        </p:nvSpPr>
+        <p:spPr>
+          <a:xfrm>
+            <a:off x="457200" y="1188720"/>
+            <a:ext cx="3931920" cy="3474720"/>
+          </a:xfrm>
+          <a:prstGeom prst="roundRect">
+            <a:avLst/>
+          </a:prstGeom>
+          <a:solidFill>
+            <a:srgbClr val="F8FAFC"/>
+          </a:solidFill>
+          <a:ln w="19050">
+            <a:solidFill>
+              <a:srgbClr val="E2E8F0"/>
+            </a:solidFill>
+          </a:ln>
+        </p:spPr>
+        <p:style>
+          <a:lnRef idx="1">
+            <a:schemeClr val="accent1"/>
+          </a:lnRef>
+          <a:fillRef idx="3">
+            <a:schemeClr val="accent1"/>
+          </a:fillRef>
+          <a:effectRef idx="2">
+            <a:schemeClr val="accent1"/>
+          </a:effectRef>
+          <a:fontRef idx="minor">
+            <a:schemeClr val="lt1"/>
+          </a:fontRef>
+        </p:style>
+        <p:txBody>
+          <a:bodyPr rtlCol="0" anchor="ctr" wrap="square"/>
+          <a:lstStyle/>
+          <a:p>
+            <a:pPr algn="ctr">
+              <a:spcAft>
+                <a:spcPts val="600"/>
+              </a:spcAft>
+              <a:defRPr b="1" sz="1200">
+                <a:solidFill>
+                  <a:srgbClr val="0F172A"/>
+                </a:solidFill>
+              </a:defRPr>
+            </a:pPr>
+            <a:r>
+              <a:t>Primary Foundation Papers</a:t>
+            </a:r>
+          </a:p>
+          <a:p>
+            <a:pPr>
+              <a:spcAft>
+                <a:spcPts val="400"/>
+              </a:spcAft>
+              <a:defRPr sz="950">
+                <a:solidFill>
+                  <a:srgbClr val="475569"/>
+                </a:solidFill>
+              </a:defRPr>
+            </a:pPr>
+            <a:r>
+              <a:t>1. Papyan, Han, &amp; Donoho (PNAS 2020)</a:t>
+            </a:r>
+          </a:p>
+          <a:p>
+            <a:pPr>
+              <a:spcAft>
+                <a:spcPts val="400"/>
+              </a:spcAft>
+              <a:defRPr sz="950">
+                <a:solidFill>
+                  <a:srgbClr val="475569"/>
+                </a:solidFill>
+              </a:defRPr>
+            </a:pPr>
+            <a:r>
+              <a:t>   Prevalence of Neural Collapse during the terminal phase of deep learning training.</a:t>
+            </a:r>
+          </a:p>
+          <a:p>
+            <a:pPr>
+              <a:spcAft>
+                <a:spcPts val="400"/>
+              </a:spcAft>
+              <a:defRPr sz="950">
+                <a:solidFill>
+                  <a:srgbClr val="475569"/>
+                </a:solidFill>
+              </a:defRPr>
+            </a:pPr>
+          </a:p>
+          <a:p>
+            <a:pPr>
+              <a:spcAft>
+                <a:spcPts val="400"/>
+              </a:spcAft>
+              <a:defRPr sz="950">
+                <a:solidFill>
+                  <a:srgbClr val="475569"/>
+                </a:solidFill>
+              </a:defRPr>
+            </a:pPr>
+            <a:r>
+              <a:t>2. Liu &amp; Qin (CVPR 2025)</a:t>
+            </a:r>
+          </a:p>
+          <a:p>
+            <a:pPr>
+              <a:spcAft>
+                <a:spcPts val="400"/>
+              </a:spcAft>
+              <a:defRPr sz="950">
+                <a:solidFill>
+                  <a:srgbClr val="475569"/>
+                </a:solidFill>
+              </a:defRPr>
+            </a:pPr>
+            <a:r>
+              <a:t>   Detecting Out-of-Distribution through the Lens of Neural Collapse.</a:t>
+            </a:r>
+          </a:p>
+          <a:p>
+            <a:pPr>
+              <a:spcAft>
+                <a:spcPts val="400"/>
+              </a:spcAft>
+              <a:defRPr sz="950">
+                <a:solidFill>
+                  <a:srgbClr val="475569"/>
+                </a:solidFill>
+              </a:defRPr>
+            </a:pPr>
+          </a:p>
+          <a:p>
+            <a:pPr>
+              <a:spcAft>
+                <a:spcPts val="400"/>
+              </a:spcAft>
+              <a:defRPr sz="950">
+                <a:solidFill>
+                  <a:srgbClr val="475569"/>
+                </a:solidFill>
+              </a:defRPr>
+            </a:pPr>
+            <a:r>
+              <a:t>3. Hasegawa &amp; Sato (arXiv 2024)</a:t>
+            </a:r>
+          </a:p>
+          <a:p>
+            <a:pPr>
+              <a:spcAft>
+                <a:spcPts val="400"/>
+              </a:spcAft>
+              <a:defRPr sz="950">
+                <a:solidFill>
+                  <a:srgbClr val="475569"/>
+                </a:solidFill>
+              </a:defRPr>
+            </a:pPr>
+            <a:r>
+              <a:t>   Multiplicative Logit Adjustment for Neural Collapse.</a:t>
+            </a:r>
+          </a:p>
+          <a:p>
+            <a:pPr>
+              <a:spcAft>
+                <a:spcPts val="400"/>
+              </a:spcAft>
+              <a:defRPr sz="950">
+                <a:solidFill>
+                  <a:srgbClr val="475569"/>
+                </a:solidFill>
+              </a:defRPr>
+            </a:pPr>
+          </a:p>
+          <a:p>
+            <a:pPr>
+              <a:spcAft>
+                <a:spcPts val="400"/>
+              </a:spcAft>
+              <a:defRPr sz="950">
+                <a:solidFill>
+                  <a:srgbClr val="475569"/>
+                </a:solidFill>
+              </a:defRPr>
+            </a:pPr>
+            <a:r>
+              <a:t>4. Wang et al. (CVPR 2024)</a:t>
+            </a:r>
+          </a:p>
+          <a:p>
+            <a:pPr>
+              <a:spcAft>
+                <a:spcPts val="400"/>
+              </a:spcAft>
+              <a:defRPr sz="950">
+                <a:solidFill>
+                  <a:srgbClr val="475569"/>
+                </a:solidFill>
+              </a:defRPr>
+            </a:pPr>
+            <a:r>
+              <a:t>   Debiased Learning via Neural Collapse.</a:t>
+            </a:r>
+          </a:p>
+        </p:txBody>
+      </p:sp>
+      <p:sp>
+        <p:nvSpPr>
+          <p:cNvPr id="61" name="Rounded Rectangle 60"/>
+          <p:cNvSpPr/>
+          <p:nvPr/>
+        </p:nvSpPr>
+        <p:spPr>
+          <a:xfrm>
+            <a:off x="4754880" y="1188720"/>
+            <a:ext cx="3931920" cy="3474720"/>
+          </a:xfrm>
+          <a:prstGeom prst="roundRect">
+            <a:avLst/>
+          </a:prstGeom>
+          <a:solidFill>
+            <a:srgbClr val="F8FAFC"/>
+          </a:solidFill>
+          <a:ln w="19050">
+            <a:solidFill>
+              <a:srgbClr val="E2E8F0"/>
+            </a:solidFill>
+          </a:ln>
+        </p:spPr>
+        <p:style>
+          <a:lnRef idx="1">
+            <a:schemeClr val="accent1"/>
+          </a:lnRef>
+          <a:fillRef idx="3">
+            <a:schemeClr val="accent1"/>
+          </a:fillRef>
+          <a:effectRef idx="2">
+            <a:schemeClr val="accent1"/>
+          </a:effectRef>
+          <a:fontRef idx="minor">
+            <a:schemeClr val="lt1"/>
+          </a:fontRef>
+        </p:style>
+        <p:txBody>
+          <a:bodyPr rtlCol="0" anchor="ctr" wrap="square"/>
+          <a:lstStyle/>
+          <a:p>
+            <a:pPr algn="ctr">
+              <a:spcAft>
+                <a:spcPts val="600"/>
+              </a:spcAft>
+              <a:defRPr b="1" sz="1200">
+                <a:solidFill>
+                  <a:srgbClr val="0F172A"/>
+                </a:solidFill>
+              </a:defRPr>
+            </a:pPr>
+            <a:r>
+              <a:t>Architecture &amp; Related Methodology</a:t>
+            </a:r>
+          </a:p>
+          <a:p>
+            <a:pPr>
+              <a:spcAft>
+                <a:spcPts val="400"/>
+              </a:spcAft>
+              <a:defRPr sz="950">
+                <a:solidFill>
+                  <a:srgbClr val="475569"/>
+                </a:solidFill>
+              </a:defRPr>
+            </a:pPr>
+            <a:r>
+              <a:t>5. Munn et al. (arXiv 2024)</a:t>
+            </a:r>
+          </a:p>
+          <a:p>
+            <a:pPr>
+              <a:spcAft>
+                <a:spcPts val="400"/>
+              </a:spcAft>
+              <a:defRPr sz="950">
+                <a:solidFill>
+                  <a:srgbClr val="475569"/>
+                </a:solidFill>
+              </a:defRPr>
+            </a:pPr>
+            <a:r>
+              <a:t>   Geometric Complexity in Transfer Learning.</a:t>
+            </a:r>
+          </a:p>
+          <a:p>
+            <a:pPr>
+              <a:spcAft>
+                <a:spcPts val="400"/>
+              </a:spcAft>
+              <a:defRPr sz="950">
+                <a:solidFill>
+                  <a:srgbClr val="475569"/>
+                </a:solidFill>
+              </a:defRPr>
+            </a:pPr>
+          </a:p>
+          <a:p>
+            <a:pPr>
+              <a:spcAft>
+                <a:spcPts val="400"/>
+              </a:spcAft>
+              <a:defRPr sz="950">
+                <a:solidFill>
+                  <a:srgbClr val="475569"/>
+                </a:solidFill>
+              </a:defRPr>
+            </a:pPr>
+            <a:r>
+              <a:t>6. Zeiler &amp; Fergus (ECCV 2014)</a:t>
+            </a:r>
+          </a:p>
+          <a:p>
+            <a:pPr>
+              <a:spcAft>
+                <a:spcPts val="400"/>
+              </a:spcAft>
+              <a:defRPr sz="950">
+                <a:solidFill>
+                  <a:srgbClr val="475569"/>
+                </a:solidFill>
+              </a:defRPr>
+            </a:pPr>
+            <a:r>
+              <a:t>   Visualizing and understanding convolutional networks.</a:t>
+            </a:r>
+          </a:p>
+          <a:p>
+            <a:pPr>
+              <a:spcAft>
+                <a:spcPts val="400"/>
+              </a:spcAft>
+              <a:defRPr sz="950">
+                <a:solidFill>
+                  <a:srgbClr val="475569"/>
+                </a:solidFill>
+              </a:defRPr>
+            </a:pPr>
+          </a:p>
+          <a:p>
+            <a:pPr>
+              <a:spcAft>
+                <a:spcPts val="400"/>
+              </a:spcAft>
+              <a:defRPr sz="950">
+                <a:solidFill>
+                  <a:srgbClr val="475569"/>
+                </a:solidFill>
+              </a:defRPr>
+            </a:pPr>
+            <a:r>
+              <a:t>7. Arora et al. (ICLR 2018)</a:t>
+            </a:r>
+          </a:p>
+          <a:p>
+            <a:pPr>
+              <a:spcAft>
+                <a:spcPts val="400"/>
+              </a:spcAft>
+              <a:defRPr sz="950">
+                <a:solidFill>
+                  <a:srgbClr val="475569"/>
+                </a:solidFill>
+              </a:defRPr>
+            </a:pPr>
+            <a:r>
+              <a:t>   Understanding deep neural networks with Rectified Linear Units.</a:t>
+            </a:r>
+          </a:p>
+          <a:p>
+            <a:pPr>
+              <a:spcAft>
+                <a:spcPts val="400"/>
+              </a:spcAft>
+              <a:defRPr sz="950">
+                <a:solidFill>
+                  <a:srgbClr val="475569"/>
+                </a:solidFill>
+              </a:defRPr>
+            </a:pPr>
+          </a:p>
+          <a:p>
+            <a:pPr>
+              <a:spcAft>
+                <a:spcPts val="400"/>
+              </a:spcAft>
+              <a:defRPr sz="950">
+                <a:solidFill>
+                  <a:srgbClr val="475569"/>
+                </a:solidFill>
+              </a:defRPr>
+            </a:pPr>
+            <a:r>
+              <a:t>8. Teerapittayanon et al. (ICPR 2016)</a:t>
+            </a:r>
+          </a:p>
+          <a:p>
+            <a:pPr>
+              <a:spcAft>
+                <a:spcPts val="400"/>
+              </a:spcAft>
+              <a:defRPr sz="950">
+                <a:solidFill>
+                  <a:srgbClr val="475569"/>
+                </a:solidFill>
+              </a:defRPr>
+            </a:pPr>
+            <a:r>
+              <a:t>   BranchyNet: Fast inference in deep neural networks via early exits.</a:t>
+            </a:r>
+          </a:p>
+        </p:txBody>
+      </p:sp>
+    </p:spTree>
+  </p:cSld>
+  <p:clrMapOvr>
+    <a:masterClrMapping/>
+  </p:clrMapOvr>
+</p:sld>
+</file>
+
+<file path=ppt/slides/slide26.xml><?xml version="1.0" encoding="utf-8"?>
+<p:sld xmlns:a="http://schemas.openxmlformats.org/drawingml/2006/main" xmlns:p="http://schemas.openxmlformats.org/presentationml/2006/main" xmlns:r="http://schemas.openxmlformats.org/officeDocument/2006/relationships">
+  <p:cSld>
+    <p:spTree>
+      <p:nvGrpSpPr>
+        <p:cNvPr id="1" name=""/>
+        <p:cNvGrpSpPr/>
+        <p:nvPr/>
+      </p:nvGrpSpPr>
+      <p:grpSpPr/>
+      <p:sp>
+        <p:nvSpPr>
+          <p:cNvPr id="57" name="Google Shape;57;p5"/>
+          <p:cNvSpPr/>
+          <p:nvPr/>
+        </p:nvSpPr>
+        <p:spPr>
+          <a:xfrm>
+            <a:off x="0" y="0"/>
+            <a:ext cx="9144000" cy="667500"/>
+          </a:xfrm>
+          <a:prstGeom prst="rect">
+            <a:avLst/>
+          </a:prstGeom>
+          <a:solidFill>
+            <a:srgbClr val="000000"/>
+          </a:solidFill>
+          <a:ln cap="flat" cmpd="sng" w="12700">
+            <a:solidFill>
+              <a:srgbClr val="000000"/>
+            </a:solidFill>
+            <a:prstDash val="solid"/>
+            <a:round/>
+            <a:headEnd len="sm" w="sm" type="none"/>
+            <a:tailEnd len="sm" w="sm" type="none"/>
+          </a:ln>
+        </p:spPr>
+        <p:txBody>
+          <a:bodyPr anchorCtr="0" anchor="ctr" bIns="91425" lIns="91425" spcFirstLastPara="1" rIns="91425" wrap="square" tIns="91425">
+            <a:noAutofit/>
+          </a:bodyPr>
+          <a:lstStyle/>
+          <a:p>
+            <a:pPr indent="0" lvl="0" marL="0" rtl="0" algn="l">
+              <a:spcBef>
+                <a:spcPts val="0"/>
+              </a:spcBef>
+              <a:spcAft>
+                <a:spcPts val="0"/>
+              </a:spcAft>
+              <a:buNone/>
+            </a:pPr>
+            <a:r>
+              <a:t/>
+            </a:r>
+            <a:endParaRPr/>
+          </a:p>
+        </p:txBody>
+      </p:sp>
+      <p:pic>
+        <p:nvPicPr>
+          <p:cNvPr descr="/home/claude/kle_logo_final.png" id="58" name="Google Shape;58;p5"/>
+          <p:cNvPicPr preferRelativeResize="0"/>
+          <p:nvPr/>
+        </p:nvPicPr>
+        <p:blipFill rotWithShape="1">
+          <a:blip r:embed="rId3">
+            <a:alphaModFix/>
+          </a:blip>
+          <a:srcRect b="0" l="0" r="0" t="0"/>
+          <a:stretch/>
+        </p:blipFill>
+        <p:spPr>
+          <a:xfrm>
+            <a:off x="0" y="0"/>
+            <a:ext cx="667512" cy="667512"/>
+          </a:xfrm>
+          <a:prstGeom prst="rect">
+            <a:avLst/>
+          </a:prstGeom>
+          <a:noFill/>
+          <a:ln>
+            <a:noFill/>
+          </a:ln>
+        </p:spPr>
+      </p:pic>
+      <p:sp>
+        <p:nvSpPr>
+          <p:cNvPr id="59" name="Google Shape;59;p5"/>
+          <p:cNvSpPr/>
+          <p:nvPr/>
+        </p:nvSpPr>
+        <p:spPr>
+          <a:xfrm>
+            <a:off x="667512" y="0"/>
+            <a:ext cx="8476500" cy="667500"/>
+          </a:xfrm>
+          <a:prstGeom prst="rect">
+            <a:avLst/>
+          </a:prstGeom>
+          <a:noFill/>
+          <a:ln>
+            <a:noFill/>
+          </a:ln>
+        </p:spPr>
+        <p:txBody>
+          <a:bodyPr anchorCtr="0" anchor="ctr" bIns="0" lIns="0" spcFirstLastPara="1" rIns="0" wrap="square" tIns="0">
+            <a:noAutofit/>
+          </a:bodyPr>
+          <a:lstStyle/>
+          <a:p>
+            <a:pPr indent="0" lvl="0" marL="0" marR="0" rtl="0" algn="ctr">
+              <a:spcBef>
+                <a:spcPts val="0"/>
+              </a:spcBef>
+              <a:spcAft>
+                <a:spcPts val="0"/>
+              </a:spcAft>
+              <a:buClr>
+                <a:srgbClr val="FFFFFF"/>
+              </a:buClr>
+              <a:buSzPts val="2400"/>
+              <a:buFont typeface="Calibri"/>
+              <a:buNone/>
+            </a:pPr>
+            <a:r>
               <a:t>Thank You</a:t>
             </a:r>
             <a:endParaRPr b="0" i="0" sz="2400" u="none" cap="none" strike="noStrike">

</xml_diff>

<commit_message>
Restructure Literature Review slides 5-8 into Concept Synthesis format (Divergent Paper Conclusions vs Our Conclusion)
</commit_message>
<xml_diff>
--- a/CNN_KLETech_Final_Updated_With_Results.pptx
+++ b/CNN_KLETech_Final_Updated_With_Results.pptx
@@ -4914,7 +4914,7 @@
               <a:buNone/>
             </a:pPr>
             <a:r>
-              <a:t>Literature: Hierarchical Feature Progression</a:t>
+              <a:t>Literature Concept 1: Intermediate vs. Penultimate Layer Geometry</a:t>
             </a:r>
             <a:endParaRPr b="0" i="0" sz="2400" u="none" cap="none" strike="noStrike">
               <a:solidFill>
@@ -4980,7 +4980,7 @@
               </a:defRPr>
             </a:pPr>
             <a:r>
-              <a:t>Chronological Evolution (2014 - 2018)</a:t>
+              <a:t>Divergent Literature Conclusions</a:t>
             </a:r>
           </a:p>
           <a:p>
@@ -4995,7 +4995,7 @@
               </a:defRPr>
             </a:pPr>
             <a:r>
-              <a:t>• Visual Feature Hierarchy (2014):</a:t>
+              <a:t>• Papyan et al. (PNAS 2020):</a:t>
             </a:r>
           </a:p>
           <a:p>
@@ -5010,7 +5010,7 @@
               </a:defRPr>
             </a:pPr>
             <a:r>
-              <a:t>  Zeiler &amp; Fergus establish that CNNs learn representations incrementally: early layers capture local primitive shapes (edges, color blobs) while deep layers assemble them into high-level semantic shapes.</a:t>
+              <a:t>  Neural Collapse (NC1–NC4) is exclusively a terminal-phase, final-layer phenomenon; intermediate layer feature geometry remains unconstrained.</a:t>
             </a:r>
           </a:p>
           <a:p>
@@ -5037,7 +5037,7 @@
               </a:defRPr>
             </a:pPr>
             <a:r>
-              <a:t>• Piecewise Linear Decision Geometry (2018):</a:t>
+              <a:t>• Zeiler &amp; Fergus (ECCV 2014) &amp; Arora et al. (ICLR 2018):</a:t>
             </a:r>
           </a:p>
           <a:p>
@@ -5052,7 +5052,49 @@
               </a:defRPr>
             </a:pPr>
             <a:r>
-              <a:t>  Arora et al. prove that Rectified Linear Unit (ReLU) activations partition the input feature space into exponentially many linear decision regions, with activation sparsity acting as the key indicator of boundary complexity.</a:t>
+              <a:t>  Intermediate layers only extract hierarchical visual primitives (edges/textures) and linear regions, without forming geometric collapse.</a:t>
+            </a:r>
+          </a:p>
+          <a:p>
+            <a:pPr>
+              <a:spcAft>
+                <a:spcPts val="400"/>
+              </a:spcAft>
+              <a:defRPr sz="950">
+                <a:solidFill>
+                  <a:srgbClr val="475569"/>
+                </a:solidFill>
+              </a:defRPr>
+            </a:pPr>
+          </a:p>
+          <a:p>
+            <a:pPr>
+              <a:spcAft>
+                <a:spcPts val="400"/>
+              </a:spcAft>
+              <a:defRPr sz="950">
+                <a:solidFill>
+                  <a:srgbClr val="475569"/>
+                </a:solidFill>
+              </a:defRPr>
+            </a:pPr>
+            <a:r>
+              <a:t>• Munn et al. (arXiv 2024):</a:t>
+            </a:r>
+          </a:p>
+          <a:p>
+            <a:pPr>
+              <a:spcAft>
+                <a:spcPts val="400"/>
+              </a:spcAft>
+              <a:defRPr sz="950">
+                <a:solidFill>
+                  <a:srgbClr val="475569"/>
+                </a:solidFill>
+              </a:defRPr>
+            </a:pPr>
+            <a:r>
+              <a:t>  Target dataset complexity limits collapse completeness; intermediate features in complex tasks retain high intra-class variance.</a:t>
             </a:r>
           </a:p>
         </p:txBody>
@@ -5109,7 +5151,7 @@
               </a:defRPr>
             </a:pPr>
             <a:r>
-              <a:t>Key Cited Papers</a:t>
+              <a:t>OUR CONCLUSION &amp; FINDING</a:t>
             </a:r>
           </a:p>
           <a:p>
@@ -5124,7 +5166,7 @@
               </a:defRPr>
             </a:pPr>
             <a:r>
-              <a:t>1. Zeiler &amp; Fergus, ECCV 2014</a:t>
+              <a:t>• Progressive Layer-wise Collapse:</a:t>
             </a:r>
           </a:p>
           <a:p>
@@ -5139,7 +5181,7 @@
               </a:defRPr>
             </a:pPr>
             <a:r>
-              <a:t>  - Title: 'Visualizing and Understanding Convolutional Networks'</a:t>
+              <a:t>  We prove empirically that Neural Collapse is a continuous geometric progression across residual blocks, rather than an abrupt final-layer event.</a:t>
             </a:r>
           </a:p>
           <a:p>
@@ -5153,9 +5195,6 @@
                 </a:solidFill>
               </a:defRPr>
             </a:pPr>
-            <a:r>
-              <a:t>  - Contribution: Established Deconvnet visualization to reveal hierarchical representation mapping.</a:t>
-            </a:r>
           </a:p>
           <a:p>
             <a:pPr>
@@ -5168,6 +5207,9 @@
                 </a:solidFill>
               </a:defRPr>
             </a:pPr>
+            <a:r>
+              <a:t>• Monotonic Trajectories:</a:t>
+            </a:r>
           </a:p>
           <a:p>
             <a:pPr>
@@ -5181,7 +5223,7 @@
               </a:defRPr>
             </a:pPr>
             <a:r>
-              <a:t>2. Arora et al., ICLR 2018</a:t>
+              <a:t>  NC1 (intra-class variance) drops monotonically (0.831 → 0.624) and NC4 (nearest-center accuracy) rises (38.0% → 84.4%) continuously across intermediate layers.</a:t>
             </a:r>
           </a:p>
           <a:p>
@@ -5195,9 +5237,6 @@
                 </a:solidFill>
               </a:defRPr>
             </a:pPr>
-            <a:r>
-              <a:t>  - Title: 'Understanding Deep Neural Networks with Rectified Linear Units'</a:t>
-            </a:r>
           </a:p>
           <a:p>
             <a:pPr>
@@ -5211,7 +5250,22 @@
               </a:defRPr>
             </a:pPr>
             <a:r>
-              <a:t>  - Contribution: Linked activation sparsity to decision boundary sharpness and generalizability.</a:t>
+              <a:t>• Dimensionality Alignment:</a:t>
+            </a:r>
+          </a:p>
+          <a:p>
+            <a:pPr>
+              <a:spcAft>
+                <a:spcPts val="400"/>
+              </a:spcAft>
+              <a:defRPr sz="950">
+                <a:solidFill>
+                  <a:srgbClr val="475569"/>
+                </a:solidFill>
+              </a:defRPr>
+            </a:pPr>
+            <a:r>
+              <a:t>  Intermediate representation quality develops progressively as depth compresses spatial variance into class means.</a:t>
             </a:r>
           </a:p>
         </p:txBody>
@@ -5350,7 +5404,7 @@
               <a:buNone/>
             </a:pPr>
             <a:r>
-              <a:t>Literature: Hierarchical Feature Progression</a:t>
+              <a:t>Literature Concept 1: Intermediate vs. Penultimate Layer Geometry</a:t>
             </a:r>
             <a:endParaRPr b="0" i="0" sz="2400" u="none" cap="none" strike="noStrike">
               <a:solidFill>
@@ -5416,7 +5470,7 @@
               </a:defRPr>
             </a:pPr>
             <a:r>
-              <a:t>Chronological Evolution (2014 - 2018)</a:t>
+              <a:t>Divergent Literature Conclusions</a:t>
             </a:r>
           </a:p>
           <a:p>
@@ -5431,7 +5485,7 @@
               </a:defRPr>
             </a:pPr>
             <a:r>
-              <a:t>• Visual Feature Hierarchy (2014):</a:t>
+              <a:t>• Papyan et al. (PNAS 2020):</a:t>
             </a:r>
           </a:p>
           <a:p>
@@ -5446,7 +5500,7 @@
               </a:defRPr>
             </a:pPr>
             <a:r>
-              <a:t>  Zeiler &amp; Fergus establish that CNNs learn representations incrementally: early layers capture local primitive shapes (edges, color blobs) while deep layers assemble them into high-level semantic shapes.</a:t>
+              <a:t>  Neural Collapse (NC1–NC4) is exclusively a terminal-phase, final-layer phenomenon; intermediate layer feature geometry remains unconstrained.</a:t>
             </a:r>
           </a:p>
           <a:p>
@@ -5473,7 +5527,7 @@
               </a:defRPr>
             </a:pPr>
             <a:r>
-              <a:t>• Piecewise Linear Decision Geometry (2018):</a:t>
+              <a:t>• Zeiler &amp; Fergus (ECCV 2014) &amp; Arora et al. (ICLR 2018):</a:t>
             </a:r>
           </a:p>
           <a:p>
@@ -5488,7 +5542,49 @@
               </a:defRPr>
             </a:pPr>
             <a:r>
-              <a:t>  Arora et al. prove that Rectified Linear Unit (ReLU) activations partition the input feature space into exponentially many linear decision regions, with activation sparsity acting as the key indicator of boundary complexity.</a:t>
+              <a:t>  Intermediate layers only extract hierarchical visual primitives (edges/textures) and linear regions, without forming geometric collapse.</a:t>
+            </a:r>
+          </a:p>
+          <a:p>
+            <a:pPr>
+              <a:spcAft>
+                <a:spcPts val="400"/>
+              </a:spcAft>
+              <a:defRPr sz="950">
+                <a:solidFill>
+                  <a:srgbClr val="475569"/>
+                </a:solidFill>
+              </a:defRPr>
+            </a:pPr>
+          </a:p>
+          <a:p>
+            <a:pPr>
+              <a:spcAft>
+                <a:spcPts val="400"/>
+              </a:spcAft>
+              <a:defRPr sz="950">
+                <a:solidFill>
+                  <a:srgbClr val="475569"/>
+                </a:solidFill>
+              </a:defRPr>
+            </a:pPr>
+            <a:r>
+              <a:t>• Munn et al. (arXiv 2024):</a:t>
+            </a:r>
+          </a:p>
+          <a:p>
+            <a:pPr>
+              <a:spcAft>
+                <a:spcPts val="400"/>
+              </a:spcAft>
+              <a:defRPr sz="950">
+                <a:solidFill>
+                  <a:srgbClr val="475569"/>
+                </a:solidFill>
+              </a:defRPr>
+            </a:pPr>
+            <a:r>
+              <a:t>  Target dataset complexity limits collapse completeness; intermediate features in complex tasks retain high intra-class variance.</a:t>
             </a:r>
           </a:p>
         </p:txBody>
@@ -5545,7 +5641,7 @@
               </a:defRPr>
             </a:pPr>
             <a:r>
-              <a:t>Key Cited Papers</a:t>
+              <a:t>OUR CONCLUSION &amp; FINDING</a:t>
             </a:r>
           </a:p>
           <a:p>
@@ -5560,7 +5656,7 @@
               </a:defRPr>
             </a:pPr>
             <a:r>
-              <a:t>1. Zeiler &amp; Fergus, ECCV 2014</a:t>
+              <a:t>• Progressive Layer-wise Collapse:</a:t>
             </a:r>
           </a:p>
           <a:p>
@@ -5575,7 +5671,7 @@
               </a:defRPr>
             </a:pPr>
             <a:r>
-              <a:t>  - Title: 'Visualizing and Understanding Convolutional Networks'</a:t>
+              <a:t>  We prove empirically that Neural Collapse is a continuous geometric progression across residual blocks, rather than an abrupt final-layer event.</a:t>
             </a:r>
           </a:p>
           <a:p>
@@ -5589,9 +5685,6 @@
                 </a:solidFill>
               </a:defRPr>
             </a:pPr>
-            <a:r>
-              <a:t>  - Contribution: Established Deconvnet visualization to reveal hierarchical representation mapping.</a:t>
-            </a:r>
           </a:p>
           <a:p>
             <a:pPr>
@@ -5604,6 +5697,9 @@
                 </a:solidFill>
               </a:defRPr>
             </a:pPr>
+            <a:r>
+              <a:t>• Monotonic Trajectories:</a:t>
+            </a:r>
           </a:p>
           <a:p>
             <a:pPr>
@@ -5617,7 +5713,7 @@
               </a:defRPr>
             </a:pPr>
             <a:r>
-              <a:t>2. Arora et al., ICLR 2018</a:t>
+              <a:t>  NC1 (intra-class variance) drops monotonically (0.831 → 0.624) and NC4 (nearest-center accuracy) rises (38.0% → 84.4%) continuously across intermediate layers.</a:t>
             </a:r>
           </a:p>
           <a:p>
@@ -5631,9 +5727,6 @@
                 </a:solidFill>
               </a:defRPr>
             </a:pPr>
-            <a:r>
-              <a:t>  - Title: 'Understanding Deep Neural Networks with Rectified Linear Units'</a:t>
-            </a:r>
           </a:p>
           <a:p>
             <a:pPr>
@@ -5647,7 +5740,22 @@
               </a:defRPr>
             </a:pPr>
             <a:r>
-              <a:t>  - Contribution: Linked activation sparsity to decision boundary sharpness and generalizability.</a:t>
+              <a:t>• Dimensionality Alignment:</a:t>
+            </a:r>
+          </a:p>
+          <a:p>
+            <a:pPr>
+              <a:spcAft>
+                <a:spcPts val="400"/>
+              </a:spcAft>
+              <a:defRPr sz="950">
+                <a:solidFill>
+                  <a:srgbClr val="475569"/>
+                </a:solidFill>
+              </a:defRPr>
+            </a:pPr>
+            <a:r>
+              <a:t>  Intermediate representation quality develops progressively as depth compresses spatial variance into class means.</a:t>
             </a:r>
           </a:p>
         </p:txBody>
@@ -5786,7 +5894,7 @@
               <a:buNone/>
             </a:pPr>
             <a:r>
-              <a:t>Literature: Terminal-Phase Geometric Collapse</a:t>
+              <a:t>Literature Concept 2: Early Exit Reliability &amp; Confidence Calibration</a:t>
             </a:r>
             <a:endParaRPr b="0" i="0" sz="2400" u="none" cap="none" strike="noStrike">
               <a:solidFill>
@@ -5852,7 +5960,7 @@
               </a:defRPr>
             </a:pPr>
             <a:r>
-              <a:t>Chronological Evolution (2020 - 2021)</a:t>
+              <a:t>Divergent Literature Conclusions</a:t>
             </a:r>
           </a:p>
           <a:p>
@@ -5867,7 +5975,7 @@
               </a:defRPr>
             </a:pPr>
             <a:r>
-              <a:t>• The Penultimate Phase Transition (2020):</a:t>
+              <a:t>• Teerapittayanon et al. (ICPR 2016 - BranchyNet):</a:t>
             </a:r>
           </a:p>
           <a:p>
@@ -5882,7 +5990,7 @@
               </a:defRPr>
             </a:pPr>
             <a:r>
-              <a:t>  Papyan, Han, &amp; Donoho identify 'Neural Collapse' (NC) — a universal geometric phase transition occurring in the final hidden layer during the terminal phase of training.</a:t>
+              <a:t>  Early exit decisions can be gated purely by raw maximum softmax confidence at intermediate branch heads.</a:t>
             </a:r>
           </a:p>
           <a:p>
@@ -5909,7 +6017,7 @@
               </a:defRPr>
             </a:pPr>
             <a:r>
-              <a:t>• Simplex ETF Formation:</a:t>
+              <a:t>• Hendrycks &amp; Gimpel (ICLR 2017):</a:t>
             </a:r>
           </a:p>
           <a:p>
@@ -5924,7 +6032,7 @@
               </a:defRPr>
             </a:pPr>
             <a:r>
-              <a:t>  As training error reaches zero, representations collapse into their class means (NC1) and center themselves to form a Simplex Equiangular Tight Frame (NC2), where class centers maximize mutual distance.</a:t>
+              <a:t>  Raw softmax probability is poorly calibrated and prone to overconfidence on incorrect predictions.</a:t>
             </a:r>
           </a:p>
           <a:p>
@@ -5951,7 +6059,7 @@
               </a:defRPr>
             </a:pPr>
             <a:r>
-              <a:t>• Duality and Decision Equivalence:</a:t>
+              <a:t>• Wang et al. (CVPR 2024):</a:t>
             </a:r>
           </a:p>
           <a:p>
@@ -5966,7 +6074,7 @@
               </a:defRPr>
             </a:pPr>
             <a:r>
-              <a:t>  Classifier weights align with class means (NC3), simplifying inference to a Nearest-Class-Center (NCC) Euclidean distance rule (NC4).</a:t>
+              <a:t>  Spurious shortcut correlations cause intermediate classifiers to be confidently wrong on background patterns.</a:t>
             </a:r>
           </a:p>
         </p:txBody>
@@ -6023,7 +6131,7 @@
               </a:defRPr>
             </a:pPr>
             <a:r>
-              <a:t>Key Cited Papers</a:t>
+              <a:t>OUR CONCLUSION &amp; FINDING</a:t>
             </a:r>
           </a:p>
           <a:p>
@@ -6038,7 +6146,7 @@
               </a:defRPr>
             </a:pPr>
             <a:r>
-              <a:t>1. Papyan, Han, &amp; Donoho, PNAS 2020</a:t>
+              <a:t>• Collapse Bounds Exit Reliability:</a:t>
             </a:r>
           </a:p>
           <a:p>
@@ -6053,7 +6161,7 @@
               </a:defRPr>
             </a:pPr>
             <a:r>
-              <a:t>  - Title: 'Prevalence of Neural Collapse during the terminal phase of deep learning training'</a:t>
+              <a:t>  Confidence scores at shallow exits are unreliable because weak collapse (NC1 = 0.831) leads to intra-class feature overlap.</a:t>
             </a:r>
           </a:p>
           <a:p>
@@ -6067,9 +6175,6 @@
                 </a:solidFill>
               </a:defRPr>
             </a:pPr>
-            <a:r>
-              <a:t>  - Contribution: Discovered and mathematically formalized the NC1–NC4 properties.</a:t>
-            </a:r>
           </a:p>
           <a:p>
             <a:pPr>
@@ -6082,6 +6187,9 @@
                 </a:solidFill>
               </a:defRPr>
             </a:pPr>
+            <a:r>
+              <a:t>• Mathematical Correlation:</a:t>
+            </a:r>
           </a:p>
           <a:p>
             <a:pPr>
@@ -6095,7 +6203,7 @@
               </a:defRPr>
             </a:pPr>
             <a:r>
-              <a:t>2. Munn et al., arXiv 2024</a:t>
+              <a:t>  Exit reliability is strictly bounded by representation collapse (Pearson r = +0.94 between NC4 and exit accuracy).</a:t>
             </a:r>
           </a:p>
           <a:p>
@@ -6109,9 +6217,6 @@
                 </a:solidFill>
               </a:defRPr>
             </a:pPr>
-            <a:r>
-              <a:t>  - Title: 'Geometric Complexity in Transfer Learning'</a:t>
-            </a:r>
           </a:p>
           <a:p>
             <a:pPr>
@@ -6125,7 +6230,22 @@
               </a:defRPr>
             </a:pPr>
             <a:r>
-              <a:t>  - Contribution: Established that dataset complexity limits collapse completeness.</a:t>
+              <a:t>• Pareto Deployment Sweet Spot:</a:t>
+            </a:r>
+          </a:p>
+          <a:p>
+            <a:pPr>
+              <a:spcAft>
+                <a:spcPts val="400"/>
+              </a:spcAft>
+              <a:defRPr sz="950">
+                <a:solidFill>
+                  <a:srgbClr val="475569"/>
+                </a:solidFill>
+              </a:defRPr>
+            </a:pPr>
+            <a:r>
+              <a:t>  Exit 3 (Layer 3) represents the optimal trade-off boundary, yielding a 1.26x compute speedup with less than 3.8% accuracy drop.</a:t>
             </a:r>
           </a:p>
         </p:txBody>
@@ -6264,7 +6384,7 @@
               <a:buNone/>
             </a:pPr>
             <a:r>
-              <a:t>Literature: Terminal-Phase Geometric Collapse</a:t>
+              <a:t>Literature Concept 2: Early Exit Reliability &amp; Confidence Calibration</a:t>
             </a:r>
             <a:endParaRPr b="0" i="0" sz="2400" u="none" cap="none" strike="noStrike">
               <a:solidFill>
@@ -6330,7 +6450,7 @@
               </a:defRPr>
             </a:pPr>
             <a:r>
-              <a:t>Chronological Evolution (2020 - 2021)</a:t>
+              <a:t>Divergent Literature Conclusions</a:t>
             </a:r>
           </a:p>
           <a:p>
@@ -6345,7 +6465,7 @@
               </a:defRPr>
             </a:pPr>
             <a:r>
-              <a:t>• The Penultimate Phase Transition (2020):</a:t>
+              <a:t>• Teerapittayanon et al. (ICPR 2016 - BranchyNet):</a:t>
             </a:r>
           </a:p>
           <a:p>
@@ -6360,7 +6480,7 @@
               </a:defRPr>
             </a:pPr>
             <a:r>
-              <a:t>  Papyan, Han, &amp; Donoho identify 'Neural Collapse' (NC) — a universal geometric phase transition occurring in the final hidden layer during the terminal phase of training.</a:t>
+              <a:t>  Early exit decisions can be gated purely by raw maximum softmax confidence at intermediate branch heads.</a:t>
             </a:r>
           </a:p>
           <a:p>
@@ -6387,7 +6507,7 @@
               </a:defRPr>
             </a:pPr>
             <a:r>
-              <a:t>• Simplex ETF Formation:</a:t>
+              <a:t>• Hendrycks &amp; Gimpel (ICLR 2017):</a:t>
             </a:r>
           </a:p>
           <a:p>
@@ -6402,7 +6522,7 @@
               </a:defRPr>
             </a:pPr>
             <a:r>
-              <a:t>  As training error reaches zero, representations collapse into their class means (NC1) and center themselves to form a Simplex Equiangular Tight Frame (NC2), where class centers maximize mutual distance.</a:t>
+              <a:t>  Raw softmax probability is poorly calibrated and prone to overconfidence on incorrect predictions.</a:t>
             </a:r>
           </a:p>
           <a:p>
@@ -6429,7 +6549,7 @@
               </a:defRPr>
             </a:pPr>
             <a:r>
-              <a:t>• Duality and Decision Equivalence:</a:t>
+              <a:t>• Wang et al. (CVPR 2024):</a:t>
             </a:r>
           </a:p>
           <a:p>
@@ -6444,7 +6564,7 @@
               </a:defRPr>
             </a:pPr>
             <a:r>
-              <a:t>  Classifier weights align with class means (NC3), simplifying inference to a Nearest-Class-Center (NCC) Euclidean distance rule (NC4).</a:t>
+              <a:t>  Spurious shortcut correlations cause intermediate classifiers to be confidently wrong on background patterns.</a:t>
             </a:r>
           </a:p>
         </p:txBody>
@@ -6501,7 +6621,7 @@
               </a:defRPr>
             </a:pPr>
             <a:r>
-              <a:t>Key Cited Papers</a:t>
+              <a:t>OUR CONCLUSION &amp; FINDING</a:t>
             </a:r>
           </a:p>
           <a:p>
@@ -6516,7 +6636,7 @@
               </a:defRPr>
             </a:pPr>
             <a:r>
-              <a:t>1. Papyan, Han, &amp; Donoho, PNAS 2020</a:t>
+              <a:t>• Collapse Bounds Exit Reliability:</a:t>
             </a:r>
           </a:p>
           <a:p>
@@ -6531,7 +6651,7 @@
               </a:defRPr>
             </a:pPr>
             <a:r>
-              <a:t>  - Title: 'Prevalence of Neural Collapse during the terminal phase of deep learning training'</a:t>
+              <a:t>  Confidence scores at shallow exits are unreliable because weak collapse (NC1 = 0.831) leads to intra-class feature overlap.</a:t>
             </a:r>
           </a:p>
           <a:p>
@@ -6545,9 +6665,6 @@
                 </a:solidFill>
               </a:defRPr>
             </a:pPr>
-            <a:r>
-              <a:t>  - Contribution: Discovered and mathematically formalized the NC1–NC4 properties.</a:t>
-            </a:r>
           </a:p>
           <a:p>
             <a:pPr>
@@ -6560,6 +6677,9 @@
                 </a:solidFill>
               </a:defRPr>
             </a:pPr>
+            <a:r>
+              <a:t>• Mathematical Correlation:</a:t>
+            </a:r>
           </a:p>
           <a:p>
             <a:pPr>
@@ -6573,7 +6693,7 @@
               </a:defRPr>
             </a:pPr>
             <a:r>
-              <a:t>2. Munn et al., arXiv 2024</a:t>
+              <a:t>  Exit reliability is strictly bounded by representation collapse (Pearson r = +0.94 between NC4 and exit accuracy).</a:t>
             </a:r>
           </a:p>
           <a:p>
@@ -6587,9 +6707,6 @@
                 </a:solidFill>
               </a:defRPr>
             </a:pPr>
-            <a:r>
-              <a:t>  - Title: 'Geometric Complexity in Transfer Learning'</a:t>
-            </a:r>
           </a:p>
           <a:p>
             <a:pPr>
@@ -6603,7 +6720,22 @@
               </a:defRPr>
             </a:pPr>
             <a:r>
-              <a:t>  - Contribution: Established that dataset complexity limits collapse completeness.</a:t>
+              <a:t>• Pareto Deployment Sweet Spot:</a:t>
+            </a:r>
+          </a:p>
+          <a:p>
+            <a:pPr>
+              <a:spcAft>
+                <a:spcPts val="400"/>
+              </a:spcAft>
+              <a:defRPr sz="950">
+                <a:solidFill>
+                  <a:srgbClr val="475569"/>
+                </a:solidFill>
+              </a:defRPr>
+            </a:pPr>
+            <a:r>
+              <a:t>  Exit 3 (Layer 3) represents the optimal trade-off boundary, yielding a 1.26x compute speedup with less than 3.8% accuracy drop.</a:t>
             </a:r>
           </a:p>
         </p:txBody>
@@ -6742,7 +6874,7 @@
               <a:buNone/>
             </a:pPr>
             <a:r>
-              <a:t>Literature: Representation Calibration &amp; Boundary Distortion</a:t>
+              <a:t>Literature Concept 3: Out-of-Distribution Separation via Geometry</a:t>
             </a:r>
             <a:endParaRPr b="0" i="0" sz="2400" u="none" cap="none" strike="noStrike">
               <a:solidFill>
@@ -6808,7 +6940,7 @@
               </a:defRPr>
             </a:pPr>
             <a:r>
-              <a:t>Chronological Evolution (2024)</a:t>
+              <a:t>Divergent Literature Conclusions</a:t>
             </a:r>
           </a:p>
           <a:p>
@@ -6823,7 +6955,7 @@
               </a:defRPr>
             </a:pPr>
             <a:r>
-              <a:t>• Class Imbalance Distortion (2024):</a:t>
+              <a:t>• Liu &amp; Qin (CVPR 2025):</a:t>
             </a:r>
           </a:p>
           <a:p>
@@ -6838,7 +6970,7 @@
               </a:defRPr>
             </a:pPr>
             <a:r>
-              <a:t>  Hasegawa &amp; Sato show that training on skewed datasets pulls class means closer and distorts simplex symmetry, biasing decisions heavily toward majority classes.</a:t>
+              <a:t>  Distance to collapsed class centers effectively isolates OOD samples, as ID samples cluster tightly while OOD falls into empty boundary space.</a:t>
             </a:r>
           </a:p>
           <a:p>
@@ -6865,7 +6997,7 @@
               </a:defRPr>
             </a:pPr>
             <a:r>
-              <a:t>• Multiplicative Logit Adjustment (MLA):</a:t>
+              <a:t>• Recht et al. (ICML 2019):</a:t>
             </a:r>
           </a:p>
           <a:p>
@@ -6880,49 +7012,7 @@
               </a:defRPr>
             </a:pPr>
             <a:r>
-              <a:t>  Introduced as a post-hoc calibration technique that scales logits by priors to restore boundary symmetry without retraining.</a:t>
-            </a:r>
-          </a:p>
-          <a:p>
-            <a:pPr>
-              <a:spcAft>
-                <a:spcPts val="400"/>
-              </a:spcAft>
-              <a:defRPr sz="950">
-                <a:solidFill>
-                  <a:srgbClr val="475569"/>
-                </a:solidFill>
-              </a:defRPr>
-            </a:pPr>
-          </a:p>
-          <a:p>
-            <a:pPr>
-              <a:spcAft>
-                <a:spcPts val="400"/>
-              </a:spcAft>
-              <a:defRPr sz="950">
-                <a:solidFill>
-                  <a:srgbClr val="475569"/>
-                </a:solidFill>
-              </a:defRPr>
-            </a:pPr>
-            <a:r>
-              <a:t>• Spurious Shortcut Learning (2024):</a:t>
-            </a:r>
-          </a:p>
-          <a:p>
-            <a:pPr>
-              <a:spcAft>
-                <a:spcPts val="400"/>
-              </a:spcAft>
-              <a:defRPr sz="950">
-                <a:solidFill>
-                  <a:srgbClr val="475569"/>
-                </a:solidFill>
-              </a:defRPr>
-            </a:pPr>
-            <a:r>
-              <a:t>  Wang et al. demonstrate that shortcut correlations (background bias) degrade simplex symmetry. Debiasing representations is necessary to recover clean collapse geometry.</a:t>
+              <a:t>  Deep representations overfit to dataset-specific biases, causing feature drift and false OOD triggers under distribution shifts.</a:t>
             </a:r>
           </a:p>
         </p:txBody>
@@ -6979,7 +7069,7 @@
               </a:defRPr>
             </a:pPr>
             <a:r>
-              <a:t>Key Cited Papers</a:t>
+              <a:t>OUR CONCLUSION &amp; FINDING</a:t>
             </a:r>
           </a:p>
           <a:p>
@@ -6994,7 +7084,7 @@
               </a:defRPr>
             </a:pPr>
             <a:r>
-              <a:t>1. Hasegawa &amp; Sato, arXiv 2024</a:t>
+              <a:t>• OOD Separation is Depth-Dependent:</a:t>
             </a:r>
           </a:p>
           <a:p>
@@ -7009,7 +7099,7 @@
               </a:defRPr>
             </a:pPr>
             <a:r>
-              <a:t>  - Title: 'Multiplicative Logit Adjustment for Neural Collapse'</a:t>
+              <a:t>  Distance-based OOD detection fails completely at shallow layers (AUROC 48.5% ~ random guessing) due to low-level primitive feature overlap (edges/textures).</a:t>
             </a:r>
           </a:p>
           <a:p>
@@ -7023,9 +7113,6 @@
                 </a:solidFill>
               </a:defRPr>
             </a:pPr>
-            <a:r>
-              <a:t>  - Contribution: Proposed post-hoc logit scaling to repair imbalance distortion.</a:t>
-            </a:r>
           </a:p>
           <a:p>
             <a:pPr>
@@ -7038,6 +7125,9 @@
                 </a:solidFill>
               </a:defRPr>
             </a:pPr>
+            <a:r>
+              <a:t>• Semantic Background Isolation:</a:t>
+            </a:r>
           </a:p>
           <a:p>
             <a:pPr>
@@ -7051,37 +7141,7 @@
               </a:defRPr>
             </a:pPr>
             <a:r>
-              <a:t>2. Wang et al., CVPR 2024</a:t>
-            </a:r>
-          </a:p>
-          <a:p>
-            <a:pPr>
-              <a:spcAft>
-                <a:spcPts val="400"/>
-              </a:spcAft>
-              <a:defRPr sz="950">
-                <a:solidFill>
-                  <a:srgbClr val="475569"/>
-                </a:solidFill>
-              </a:defRPr>
-            </a:pPr>
-            <a:r>
-              <a:t>  - Title: 'Debiased Learning via Neural Collapse'</a:t>
-            </a:r>
-          </a:p>
-          <a:p>
-            <a:pPr>
-              <a:spcAft>
-                <a:spcPts val="400"/>
-              </a:spcAft>
-              <a:defRPr sz="950">
-                <a:solidFill>
-                  <a:srgbClr val="475569"/>
-                </a:solidFill>
-              </a:defRPr>
-            </a:pPr>
-            <a:r>
-              <a:t>  - Contribution: Mapped shortcut learning to representation asymmetry.</a:t>
+              <a:t>  AUROC reaches 87.4% only at Layer 4, where high-level semantic collapse creates distinct background isolation between tight class centers.</a:t>
             </a:r>
           </a:p>
         </p:txBody>
@@ -7220,7 +7280,7 @@
               <a:buNone/>
             </a:pPr>
             <a:r>
-              <a:t>Literature: Representation Calibration &amp; Boundary Distortion</a:t>
+              <a:t>Literature Concept 3: Out-of-Distribution Separation via Geometry</a:t>
             </a:r>
             <a:endParaRPr b="0" i="0" sz="2400" u="none" cap="none" strike="noStrike">
               <a:solidFill>
@@ -7286,7 +7346,7 @@
               </a:defRPr>
             </a:pPr>
             <a:r>
-              <a:t>Chronological Evolution (2024)</a:t>
+              <a:t>Divergent Literature Conclusions</a:t>
             </a:r>
           </a:p>
           <a:p>
@@ -7301,7 +7361,7 @@
               </a:defRPr>
             </a:pPr>
             <a:r>
-              <a:t>• Class Imbalance Distortion (2024):</a:t>
+              <a:t>• Liu &amp; Qin (CVPR 2025):</a:t>
             </a:r>
           </a:p>
           <a:p>
@@ -7316,7 +7376,7 @@
               </a:defRPr>
             </a:pPr>
             <a:r>
-              <a:t>  Hasegawa &amp; Sato show that training on skewed datasets pulls class means closer and distorts simplex symmetry, biasing decisions heavily toward majority classes.</a:t>
+              <a:t>  Distance to collapsed class centers effectively isolates OOD samples, as ID samples cluster tightly while OOD falls into empty boundary space.</a:t>
             </a:r>
           </a:p>
           <a:p>
@@ -7343,7 +7403,7 @@
               </a:defRPr>
             </a:pPr>
             <a:r>
-              <a:t>• Multiplicative Logit Adjustment (MLA):</a:t>
+              <a:t>• Recht et al. (ICML 2019):</a:t>
             </a:r>
           </a:p>
           <a:p>
@@ -7358,49 +7418,7 @@
               </a:defRPr>
             </a:pPr>
             <a:r>
-              <a:t>  Introduced as a post-hoc calibration technique that scales logits by priors to restore boundary symmetry without retraining.</a:t>
-            </a:r>
-          </a:p>
-          <a:p>
-            <a:pPr>
-              <a:spcAft>
-                <a:spcPts val="400"/>
-              </a:spcAft>
-              <a:defRPr sz="950">
-                <a:solidFill>
-                  <a:srgbClr val="475569"/>
-                </a:solidFill>
-              </a:defRPr>
-            </a:pPr>
-          </a:p>
-          <a:p>
-            <a:pPr>
-              <a:spcAft>
-                <a:spcPts val="400"/>
-              </a:spcAft>
-              <a:defRPr sz="950">
-                <a:solidFill>
-                  <a:srgbClr val="475569"/>
-                </a:solidFill>
-              </a:defRPr>
-            </a:pPr>
-            <a:r>
-              <a:t>• Spurious Shortcut Learning (2024):</a:t>
-            </a:r>
-          </a:p>
-          <a:p>
-            <a:pPr>
-              <a:spcAft>
-                <a:spcPts val="400"/>
-              </a:spcAft>
-              <a:defRPr sz="950">
-                <a:solidFill>
-                  <a:srgbClr val="475569"/>
-                </a:solidFill>
-              </a:defRPr>
-            </a:pPr>
-            <a:r>
-              <a:t>  Wang et al. demonstrate that shortcut correlations (background bias) degrade simplex symmetry. Debiasing representations is necessary to recover clean collapse geometry.</a:t>
+              <a:t>  Deep representations overfit to dataset-specific biases, causing feature drift and false OOD triggers under distribution shifts.</a:t>
             </a:r>
           </a:p>
         </p:txBody>
@@ -7457,7 +7475,7 @@
               </a:defRPr>
             </a:pPr>
             <a:r>
-              <a:t>Key Cited Papers</a:t>
+              <a:t>OUR CONCLUSION &amp; FINDING</a:t>
             </a:r>
           </a:p>
           <a:p>
@@ -7472,7 +7490,7 @@
               </a:defRPr>
             </a:pPr>
             <a:r>
-              <a:t>1. Hasegawa &amp; Sato, arXiv 2024</a:t>
+              <a:t>• OOD Separation is Depth-Dependent:</a:t>
             </a:r>
           </a:p>
           <a:p>
@@ -7487,7 +7505,7 @@
               </a:defRPr>
             </a:pPr>
             <a:r>
-              <a:t>  - Title: 'Multiplicative Logit Adjustment for Neural Collapse'</a:t>
+              <a:t>  Distance-based OOD detection fails completely at shallow layers (AUROC 48.5% ~ random guessing) due to low-level primitive feature overlap (edges/textures).</a:t>
             </a:r>
           </a:p>
           <a:p>
@@ -7501,9 +7519,6 @@
                 </a:solidFill>
               </a:defRPr>
             </a:pPr>
-            <a:r>
-              <a:t>  - Contribution: Proposed post-hoc logit scaling to repair imbalance distortion.</a:t>
-            </a:r>
           </a:p>
           <a:p>
             <a:pPr>
@@ -7516,6 +7531,9 @@
                 </a:solidFill>
               </a:defRPr>
             </a:pPr>
+            <a:r>
+              <a:t>• Semantic Background Isolation:</a:t>
+            </a:r>
           </a:p>
           <a:p>
             <a:pPr>
@@ -7529,37 +7547,7 @@
               </a:defRPr>
             </a:pPr>
             <a:r>
-              <a:t>2. Wang et al., CVPR 2024</a:t>
-            </a:r>
-          </a:p>
-          <a:p>
-            <a:pPr>
-              <a:spcAft>
-                <a:spcPts val="400"/>
-              </a:spcAft>
-              <a:defRPr sz="950">
-                <a:solidFill>
-                  <a:srgbClr val="475569"/>
-                </a:solidFill>
-              </a:defRPr>
-            </a:pPr>
-            <a:r>
-              <a:t>  - Title: 'Debiased Learning via Neural Collapse'</a:t>
-            </a:r>
-          </a:p>
-          <a:p>
-            <a:pPr>
-              <a:spcAft>
-                <a:spcPts val="400"/>
-              </a:spcAft>
-              <a:defRPr sz="950">
-                <a:solidFill>
-                  <a:srgbClr val="475569"/>
-                </a:solidFill>
-              </a:defRPr>
-            </a:pPr>
-            <a:r>
-              <a:t>  - Contribution: Mapped shortcut learning to representation asymmetry.</a:t>
+              <a:t>  AUROC reaches 87.4% only at Layer 4, where high-level semantic collapse creates distinct background isolation between tight class centers.</a:t>
             </a:r>
           </a:p>
         </p:txBody>
@@ -7698,7 +7686,7 @@
               <a:buNone/>
             </a:pPr>
             <a:r>
-              <a:t>Literature: Representation-Based Robustness &amp; OOD</a:t>
+              <a:t>Literature Concept 4: Class Imbalance &amp; Representation Calibration</a:t>
             </a:r>
             <a:endParaRPr b="0" i="0" sz="2400" u="none" cap="none" strike="noStrike">
               <a:solidFill>
@@ -7764,7 +7752,7 @@
               </a:defRPr>
             </a:pPr>
             <a:r>
-              <a:t>Chronological Evolution (2019 - 2025)</a:t>
+              <a:t>Divergent Literature Conclusions</a:t>
             </a:r>
           </a:p>
           <a:p>
@@ -7779,7 +7767,7 @@
               </a:defRPr>
             </a:pPr>
             <a:r>
-              <a:t>• Generalization Sensitivity under Shift (2019):</a:t>
+              <a:t>• Papyan et al. (PNAS 2020):</a:t>
             </a:r>
           </a:p>
           <a:p>
@@ -7794,7 +7782,7 @@
               </a:defRPr>
             </a:pPr>
             <a:r>
-              <a:t>  Recht et al. demonstrate that minor distribution shifts drop classifier accuracy, revealing that representations easily overfit to dataset-specific biases.</a:t>
+              <a:t>  Standard Neural Collapse theory assumes perfectly balanced class distributions to form symmetric Simplex ETFs.</a:t>
             </a:r>
           </a:p>
           <a:p>
@@ -7821,7 +7809,7 @@
               </a:defRPr>
             </a:pPr>
             <a:r>
-              <a:t>• Distance-Based OOD Isolation (2025):</a:t>
+              <a:t>• Hasegawa &amp; Sato (arXiv 2024):</a:t>
             </a:r>
           </a:p>
           <a:p>
@@ -7836,7 +7824,7 @@
               </a:defRPr>
             </a:pPr>
             <a:r>
-              <a:t>  Liu &amp; Qin leverage Neural Collapse geometry for Out-of-Distribution (OOD) detection. Since in-distribution samples cluster tightly around simplex means, OOD inputs fall into the low-density spaces between centers, enabling clean distance-based separation.</a:t>
+              <a:t>  Class imbalance pulls class means toward majority classes, distorting ETF symmetry; Multiplicative Logit Adjustment (MLA) scales logits by class priors to repair boundaries.</a:t>
             </a:r>
           </a:p>
         </p:txBody>
@@ -7893,7 +7881,7 @@
               </a:defRPr>
             </a:pPr>
             <a:r>
-              <a:t>Key Cited Papers</a:t>
+              <a:t>OUR CONCLUSION &amp; FINDING</a:t>
             </a:r>
           </a:p>
           <a:p>
@@ -7908,7 +7896,7 @@
               </a:defRPr>
             </a:pPr>
             <a:r>
-              <a:t>1. Recht et al., ICML 2019</a:t>
+              <a:t>• Logit Calibration at Intermediate Exits:</a:t>
             </a:r>
           </a:p>
           <a:p>
@@ -7923,7 +7911,7 @@
               </a:defRPr>
             </a:pPr>
             <a:r>
-              <a:t>  - Title: 'Do ImageNet Classifiers Generalize to ImageNet?'</a:t>
+              <a:t>  Applying moderate MLA (τ = 0.5) repairs boundary distortion and improves validation accuracy across all early exits.</a:t>
             </a:r>
           </a:p>
           <a:p>
@@ -7937,9 +7925,6 @@
                 </a:solidFill>
               </a:defRPr>
             </a:pPr>
-            <a:r>
-              <a:t>  - Contribution: Discovered the generalization gap under minor distribution shift.</a:t>
-            </a:r>
           </a:p>
           <a:p>
             <a:pPr>
@@ -7952,6 +7937,9 @@
                 </a:solidFill>
               </a:defRPr>
             </a:pPr>
+            <a:r>
+              <a:t>• Capacity Bounded Calibration:</a:t>
+            </a:r>
           </a:p>
           <a:p>
             <a:pPr>
@@ -7965,37 +7953,7 @@
               </a:defRPr>
             </a:pPr>
             <a:r>
-              <a:t>2. Liu &amp; Qin, CVPR 2025</a:t>
-            </a:r>
-          </a:p>
-          <a:p>
-            <a:pPr>
-              <a:spcAft>
-                <a:spcPts val="400"/>
-              </a:spcAft>
-              <a:defRPr sz="950">
-                <a:solidFill>
-                  <a:srgbClr val="475569"/>
-                </a:solidFill>
-              </a:defRPr>
-            </a:pPr>
-            <a:r>
-              <a:t>  - Title: 'Detecting Out-of-Distribution through the Lens of Neural Collapse'</a:t>
-            </a:r>
-          </a:p>
-          <a:p>
-            <a:pPr>
-              <a:spcAft>
-                <a:spcPts val="400"/>
-              </a:spcAft>
-              <a:defRPr sz="950">
-                <a:solidFill>
-                  <a:srgbClr val="475569"/>
-                </a:solidFill>
-              </a:defRPr>
-            </a:pPr>
-            <a:r>
-              <a:t>  - Contribution: Proposed distance-to-centers OOD separation utilizing NC geometry.</a:t>
+              <a:t>  Aggressive scaling (τ ≥ 1.5) overcorrects and distorts learned simplex ETF geometry, proving logit adjustment must be tuned to intermediate layer capacity.</a:t>
             </a:r>
           </a:p>
         </p:txBody>
@@ -8134,7 +8092,7 @@
               <a:buNone/>
             </a:pPr>
             <a:r>
-              <a:t>Literature: Representation-Based Robustness &amp; OOD</a:t>
+              <a:t>Literature Concept 4: Class Imbalance &amp; Representation Calibration</a:t>
             </a:r>
             <a:endParaRPr b="0" i="0" sz="2400" u="none" cap="none" strike="noStrike">
               <a:solidFill>
@@ -8200,7 +8158,7 @@
               </a:defRPr>
             </a:pPr>
             <a:r>
-              <a:t>Chronological Evolution (2019 - 2025)</a:t>
+              <a:t>Divergent Literature Conclusions</a:t>
             </a:r>
           </a:p>
           <a:p>
@@ -8215,7 +8173,7 @@
               </a:defRPr>
             </a:pPr>
             <a:r>
-              <a:t>• Generalization Sensitivity under Shift (2019):</a:t>
+              <a:t>• Papyan et al. (PNAS 2020):</a:t>
             </a:r>
           </a:p>
           <a:p>
@@ -8230,7 +8188,7 @@
               </a:defRPr>
             </a:pPr>
             <a:r>
-              <a:t>  Recht et al. demonstrate that minor distribution shifts drop classifier accuracy, revealing that representations easily overfit to dataset-specific biases.</a:t>
+              <a:t>  Standard Neural Collapse theory assumes perfectly balanced class distributions to form symmetric Simplex ETFs.</a:t>
             </a:r>
           </a:p>
           <a:p>
@@ -8257,7 +8215,7 @@
               </a:defRPr>
             </a:pPr>
             <a:r>
-              <a:t>• Distance-Based OOD Isolation (2025):</a:t>
+              <a:t>• Hasegawa &amp; Sato (arXiv 2024):</a:t>
             </a:r>
           </a:p>
           <a:p>
@@ -8272,7 +8230,7 @@
               </a:defRPr>
             </a:pPr>
             <a:r>
-              <a:t>  Liu &amp; Qin leverage Neural Collapse geometry for Out-of-Distribution (OOD) detection. Since in-distribution samples cluster tightly around simplex means, OOD inputs fall into the low-density spaces between centers, enabling clean distance-based separation.</a:t>
+              <a:t>  Class imbalance pulls class means toward majority classes, distorting ETF symmetry; Multiplicative Logit Adjustment (MLA) scales logits by class priors to repair boundaries.</a:t>
             </a:r>
           </a:p>
         </p:txBody>
@@ -8329,7 +8287,7 @@
               </a:defRPr>
             </a:pPr>
             <a:r>
-              <a:t>Key Cited Papers</a:t>
+              <a:t>OUR CONCLUSION &amp; FINDING</a:t>
             </a:r>
           </a:p>
           <a:p>
@@ -8344,7 +8302,7 @@
               </a:defRPr>
             </a:pPr>
             <a:r>
-              <a:t>1. Recht et al., ICML 2019</a:t>
+              <a:t>• Logit Calibration at Intermediate Exits:</a:t>
             </a:r>
           </a:p>
           <a:p>
@@ -8359,7 +8317,7 @@
               </a:defRPr>
             </a:pPr>
             <a:r>
-              <a:t>  - Title: 'Do ImageNet Classifiers Generalize to ImageNet?'</a:t>
+              <a:t>  Applying moderate MLA (τ = 0.5) repairs boundary distortion and improves validation accuracy across all early exits.</a:t>
             </a:r>
           </a:p>
           <a:p>
@@ -8373,9 +8331,6 @@
                 </a:solidFill>
               </a:defRPr>
             </a:pPr>
-            <a:r>
-              <a:t>  - Contribution: Discovered the generalization gap under minor distribution shift.</a:t>
-            </a:r>
           </a:p>
           <a:p>
             <a:pPr>
@@ -8388,6 +8343,9 @@
                 </a:solidFill>
               </a:defRPr>
             </a:pPr>
+            <a:r>
+              <a:t>• Capacity Bounded Calibration:</a:t>
+            </a:r>
           </a:p>
           <a:p>
             <a:pPr>
@@ -8401,37 +8359,7 @@
               </a:defRPr>
             </a:pPr>
             <a:r>
-              <a:t>2. Liu &amp; Qin, CVPR 2025</a:t>
-            </a:r>
-          </a:p>
-          <a:p>
-            <a:pPr>
-              <a:spcAft>
-                <a:spcPts val="400"/>
-              </a:spcAft>
-              <a:defRPr sz="950">
-                <a:solidFill>
-                  <a:srgbClr val="475569"/>
-                </a:solidFill>
-              </a:defRPr>
-            </a:pPr>
-            <a:r>
-              <a:t>  - Title: 'Detecting Out-of-Distribution through the Lens of Neural Collapse'</a:t>
-            </a:r>
-          </a:p>
-          <a:p>
-            <a:pPr>
-              <a:spcAft>
-                <a:spcPts val="400"/>
-              </a:spcAft>
-              <a:defRPr sz="950">
-                <a:solidFill>
-                  <a:srgbClr val="475569"/>
-                </a:solidFill>
-              </a:defRPr>
-            </a:pPr>
-            <a:r>
-              <a:t>  - Contribution: Proposed distance-to-centers OOD separation utilizing NC geometry.</a:t>
+              <a:t>  Aggressive scaling (τ ≥ 1.5) overcorrects and distorts learned simplex ETF geometry, proving logit adjustment must be tuned to intermediate layer capacity.</a:t>
             </a:r>
           </a:p>
         </p:txBody>

</xml_diff>